<commit_message>
Restructure funding deck to 4 slides (state→proposal→closing)
Drops the v1/v2 comparison and rationale pages. New flow:
1. Cover (funding need BA $0.4bn / OT $1.0bn / $1.4bn)
2. Current state & retrofit — BA/OT key financials (left) + retrofit
   capex and expected effect (right)
3. Funding proposal — OT DOE/ATVM loan terms → BA-centered funding +
   grant maximization request
4. Government communication (closing)

render_funding.js slide list updated to 4; doc deck note synced.

Co-Authored-By: Claude Opus 4.8 <noreply@anthropic.com>
Claude-Session: https://claude.ai/code/session_019MWAFoC5mEReHSPt6vQXor
</commit_message>
<xml_diff>
--- a/sk_valuation_project/output/SK_Funding_v3.pptx
+++ b/sk_valuation_project/output/SK_Funding_v3.pptx
@@ -9,10 +9,9 @@
     <p:sldId id="257" r:id="rId3"/>
     <p:sldId id="258" r:id="rId4"/>
     <p:sldId id="259" r:id="rId5"/>
-    <p:sldId id="260" r:id="rId6"/>
   </p:sldIdLst>
   <p:notesMasterIdLst>
-    <p:notesMasterId r:id="rId7"/>
+    <p:notesMasterId r:id="rId6"/>
   </p:notesMasterIdLst>
   <p:sldSz cx="10689336" cy="7562088"/>
   <p:notesSz cx="7562088" cy="10689336"/>
@@ -794,94 +793,6 @@
             <a:fld id="{F7021451-1387-4CA6-816F-3879F97B5CBC}" type="slidenum">
               <a:rPr lang="en-US"/>
               <a:t>4</a:t>
-            </a:fld>
-            <a:endParaRPr lang="en-US"/>
-          </a:p>
-        </p:txBody>
-      </p:sp>
-    </p:spTree>
-    <p:extLst>
-      <p:ext uri="{BB962C8B-B14F-4D97-AF65-F5344CB8AC3E}">
-        <p14:creationId xmlns:p14="http://schemas.microsoft.com/office/powerpoint/2010/main" val="1024086991"/>
-      </p:ext>
-    </p:extLst>
-  </p:cSld>
-  <p:clrMapOvr>
-    <a:masterClrMapping/>
-  </p:clrMapOvr>
-</p:notes>
-</file>
-
-<file path=ppt/notesSlides/notesSlide5.xml><?xml version="1.0" encoding="utf-8"?>
-<p:notes xmlns:a="http://schemas.openxmlformats.org/drawingml/2006/main" xmlns:r="http://schemas.openxmlformats.org/officeDocument/2006/relationships" xmlns:p="http://schemas.openxmlformats.org/presentationml/2006/main">
-  <p:cSld>
-    <p:spTree>
-      <p:nvGrpSpPr>
-        <p:cNvPr id="1" name=""/>
-        <p:cNvGrpSpPr/>
-        <p:nvPr/>
-      </p:nvGrpSpPr>
-      <p:grpSpPr>
-        <a:xfrm>
-          <a:off x="0" y="0"/>
-          <a:ext cx="0" cy="0"/>
-          <a:chOff x="0" y="0"/>
-          <a:chExt cx="0" cy="0"/>
-        </a:xfrm>
-      </p:grpSpPr>
-      <p:sp>
-        <p:nvSpPr>
-          <p:cNvPr id="2" name="Slide Image Placeholder 1"/>
-          <p:cNvSpPr>
-            <a:spLocks noGrp="1" noRot="1" noChangeAspect="1"/>
-          </p:cNvSpPr>
-          <p:nvPr>
-            <p:ph type="sldImg"/>
-          </p:nvPr>
-        </p:nvSpPr>
-        <p:spPr/>
-      </p:sp>
-      <p:sp>
-        <p:nvSpPr>
-          <p:cNvPr id="3" name="Notes Placeholder 2"/>
-          <p:cNvSpPr>
-            <a:spLocks noGrp="1"/>
-          </p:cNvSpPr>
-          <p:nvPr>
-            <p:ph type="body" idx="1"/>
-          </p:nvPr>
-        </p:nvSpPr>
-        <p:spPr/>
-        <p:txBody>
-          <a:bodyPr/>
-          <a:lstStyle/>
-          <a:p>
-            <a:r>
-              <a:rPr lang="en-US" dirty="0"/>
-              <a:t/>
-            </a:r>
-            <a:endParaRPr lang="en-US" dirty="0"/>
-          </a:p>
-        </p:txBody>
-      </p:sp>
-      <p:sp>
-        <p:nvSpPr>
-          <p:cNvPr id="4" name="Slide Number Placeholder 3"/>
-          <p:cNvSpPr>
-            <a:spLocks noGrp="1"/>
-          </p:cNvSpPr>
-          <p:nvPr>
-            <p:ph type="sldNum" sz="quarter" idx="10"/>
-          </p:nvPr>
-        </p:nvSpPr>
-        <p:spPr/>
-        <p:txBody>
-          <a:bodyPr/>
-          <a:lstStyle/>
-          <a:p>
-            <a:fld id="{F7021451-1387-4CA6-816F-3879F97B5CBC}" type="slidenum">
-              <a:rPr lang="en-US"/>
-              <a:t>5</a:t>
             </a:fld>
             <a:endParaRPr lang="en-US"/>
           </a:p>
@@ -1402,62 +1313,6 @@
       <p:pic>
         <p:nvPicPr>
           <p:cNvPr id="2" name="Image 0" descr="/home/user/bm-x7k2/sk_valuation_project/output/funding_png/s4.png">    </p:cNvPr>
-          <p:cNvPicPr>
-            <a:picLocks noChangeAspect="1"/>
-          </p:cNvPicPr>
-          <p:nvPr/>
-        </p:nvPicPr>
-        <p:blipFill>
-          <a:blip r:embed="rId1"/>
-          <a:stretch>
-            <a:fillRect/>
-          </a:stretch>
-        </p:blipFill>
-        <p:spPr>
-          <a:xfrm>
-            <a:off x="0" y="0"/>
-            <a:ext cx="10689336" cy="7562088"/>
-          </a:xfrm>
-          <a:prstGeom prst="rect">
-            <a:avLst/>
-          </a:prstGeom>
-        </p:spPr>
-      </p:pic>
-    </p:spTree>
-  </p:cSld>
-  <p:clrMapOvr>
-    <a:masterClrMapping/>
-  </p:clrMapOvr>
-</p:sld>
-</file>
-
-<file path=ppt/slides/slide5.xml><?xml version="1.0" encoding="utf-8"?>
-<p:sld xmlns:a="http://schemas.openxmlformats.org/drawingml/2006/main" xmlns:r="http://schemas.openxmlformats.org/officeDocument/2006/relationships" xmlns:p="http://schemas.openxmlformats.org/presentationml/2006/main">
-  <p:cSld name="Slide 5">
-    <p:bg>
-      <p:bgPr>
-        <a:solidFill>
-          <a:srgbClr val="FAF7F1"/>
-        </a:solidFill>
-      </p:bgPr>
-    </p:bg>
-    <p:spTree>
-      <p:nvGrpSpPr>
-        <p:cNvPr id="1" name=""/>
-        <p:cNvGrpSpPr/>
-        <p:nvPr/>
-      </p:nvGrpSpPr>
-      <p:grpSpPr>
-        <a:xfrm>
-          <a:off x="0" y="0"/>
-          <a:ext cx="0" cy="0"/>
-          <a:chOff x="0" y="0"/>
-          <a:chExt cx="0" cy="0"/>
-        </a:xfrm>
-      </p:grpSpPr>
-      <p:pic>
-        <p:nvPicPr>
-          <p:cNvPr id="2" name="Image 0" descr="/home/user/bm-x7k2/sk_valuation_project/output/funding_png/s5.png">    </p:cNvPr>
           <p:cNvPicPr>
             <a:picLocks noChangeAspect="1"/>
           </p:cNvPicPr>

</xml_diff>

<commit_message>
Remove mezzanine from model; add football-field slide; enrich deck
Model: pref_bal=0 removes mezzanine — OT's $1.0bn is funded by BA equity
injection (equity-down), so returns are read off common-stock FCFE (Ke)
rather than mezz DSCR. Regenerated FCFF_model_lines.xlsx.

Deck (now 5 slides, SK earnings template via HTML→PNG, Space Grotesk
hero numbers per the handoff guideline):
- New P4 Football Field (BA consolidated): DCF / EV-EBITDA / NAV ranges,
  conclusion band $3.0-4.0bn, equity-return callout
- P1 cover: drop the funding-need panel (lives on P2 now)
- P2: 2x2 KPI cards (capacity / existing debt / retrofit / ASP)
- P5: indicative engagement timeline strip to fill whitespace
- installed Space Grotesk + Noto Serif KR/IBM Plex fonts for rendering

Co-Authored-By: Claude Opus 4.8 <noreply@anthropic.com>
Claude-Session: https://claude.ai/code/session_019MWAFoC5mEReHSPt6vQXor
</commit_message>
<xml_diff>
--- a/sk_valuation_project/output/SK_Funding_v3.pptx
+++ b/sk_valuation_project/output/SK_Funding_v3.pptx
@@ -9,9 +9,10 @@
     <p:sldId id="257" r:id="rId3"/>
     <p:sldId id="258" r:id="rId4"/>
     <p:sldId id="259" r:id="rId5"/>
+    <p:sldId id="260" r:id="rId6"/>
   </p:sldIdLst>
   <p:notesMasterIdLst>
-    <p:notesMasterId r:id="rId6"/>
+    <p:notesMasterId r:id="rId7"/>
   </p:notesMasterIdLst>
   <p:sldSz cx="10689336" cy="7562088"/>
   <p:notesSz cx="7562088" cy="10689336"/>
@@ -793,6 +794,94 @@
             <a:fld id="{F7021451-1387-4CA6-816F-3879F97B5CBC}" type="slidenum">
               <a:rPr lang="en-US"/>
               <a:t>4</a:t>
+            </a:fld>
+            <a:endParaRPr lang="en-US"/>
+          </a:p>
+        </p:txBody>
+      </p:sp>
+    </p:spTree>
+    <p:extLst>
+      <p:ext uri="{BB962C8B-B14F-4D97-AF65-F5344CB8AC3E}">
+        <p14:creationId xmlns:p14="http://schemas.microsoft.com/office/powerpoint/2010/main" val="1024086991"/>
+      </p:ext>
+    </p:extLst>
+  </p:cSld>
+  <p:clrMapOvr>
+    <a:masterClrMapping/>
+  </p:clrMapOvr>
+</p:notes>
+</file>
+
+<file path=ppt/notesSlides/notesSlide5.xml><?xml version="1.0" encoding="utf-8"?>
+<p:notes xmlns:a="http://schemas.openxmlformats.org/drawingml/2006/main" xmlns:r="http://schemas.openxmlformats.org/officeDocument/2006/relationships" xmlns:p="http://schemas.openxmlformats.org/presentationml/2006/main">
+  <p:cSld>
+    <p:spTree>
+      <p:nvGrpSpPr>
+        <p:cNvPr id="1" name=""/>
+        <p:cNvGrpSpPr/>
+        <p:nvPr/>
+      </p:nvGrpSpPr>
+      <p:grpSpPr>
+        <a:xfrm>
+          <a:off x="0" y="0"/>
+          <a:ext cx="0" cy="0"/>
+          <a:chOff x="0" y="0"/>
+          <a:chExt cx="0" cy="0"/>
+        </a:xfrm>
+      </p:grpSpPr>
+      <p:sp>
+        <p:nvSpPr>
+          <p:cNvPr id="2" name="Slide Image Placeholder 1"/>
+          <p:cNvSpPr>
+            <a:spLocks noGrp="1" noRot="1" noChangeAspect="1"/>
+          </p:cNvSpPr>
+          <p:nvPr>
+            <p:ph type="sldImg"/>
+          </p:nvPr>
+        </p:nvSpPr>
+        <p:spPr/>
+      </p:sp>
+      <p:sp>
+        <p:nvSpPr>
+          <p:cNvPr id="3" name="Notes Placeholder 2"/>
+          <p:cNvSpPr>
+            <a:spLocks noGrp="1"/>
+          </p:cNvSpPr>
+          <p:nvPr>
+            <p:ph type="body" idx="1"/>
+          </p:nvPr>
+        </p:nvSpPr>
+        <p:spPr/>
+        <p:txBody>
+          <a:bodyPr/>
+          <a:lstStyle/>
+          <a:p>
+            <a:r>
+              <a:rPr lang="en-US" dirty="0"/>
+              <a:t/>
+            </a:r>
+            <a:endParaRPr lang="en-US" dirty="0"/>
+          </a:p>
+        </p:txBody>
+      </p:sp>
+      <p:sp>
+        <p:nvSpPr>
+          <p:cNvPr id="4" name="Slide Number Placeholder 3"/>
+          <p:cNvSpPr>
+            <a:spLocks noGrp="1"/>
+          </p:cNvSpPr>
+          <p:nvPr>
+            <p:ph type="sldNum" sz="quarter" idx="10"/>
+          </p:nvPr>
+        </p:nvSpPr>
+        <p:spPr/>
+        <p:txBody>
+          <a:bodyPr/>
+          <a:lstStyle/>
+          <a:p>
+            <a:fld id="{F7021451-1387-4CA6-816F-3879F97B5CBC}" type="slidenum">
+              <a:rPr lang="en-US"/>
+              <a:t>5</a:t>
             </a:fld>
             <a:endParaRPr lang="en-US"/>
           </a:p>
@@ -1313,6 +1402,62 @@
       <p:pic>
         <p:nvPicPr>
           <p:cNvPr id="2" name="Image 0" descr="/home/user/bm-x7k2/sk_valuation_project/output/funding_png/s4.png">    </p:cNvPr>
+          <p:cNvPicPr>
+            <a:picLocks noChangeAspect="1"/>
+          </p:cNvPicPr>
+          <p:nvPr/>
+        </p:nvPicPr>
+        <p:blipFill>
+          <a:blip r:embed="rId1"/>
+          <a:stretch>
+            <a:fillRect/>
+          </a:stretch>
+        </p:blipFill>
+        <p:spPr>
+          <a:xfrm>
+            <a:off x="0" y="0"/>
+            <a:ext cx="10689336" cy="7562088"/>
+          </a:xfrm>
+          <a:prstGeom prst="rect">
+            <a:avLst/>
+          </a:prstGeom>
+        </p:spPr>
+      </p:pic>
+    </p:spTree>
+  </p:cSld>
+  <p:clrMapOvr>
+    <a:masterClrMapping/>
+  </p:clrMapOvr>
+</p:sld>
+</file>
+
+<file path=ppt/slides/slide5.xml><?xml version="1.0" encoding="utf-8"?>
+<p:sld xmlns:a="http://schemas.openxmlformats.org/drawingml/2006/main" xmlns:r="http://schemas.openxmlformats.org/officeDocument/2006/relationships" xmlns:p="http://schemas.openxmlformats.org/presentationml/2006/main">
+  <p:cSld name="Slide 5">
+    <p:bg>
+      <p:bgPr>
+        <a:solidFill>
+          <a:srgbClr val="FAF7F1"/>
+        </a:solidFill>
+      </p:bgPr>
+    </p:bg>
+    <p:spTree>
+      <p:nvGrpSpPr>
+        <p:cNvPr id="1" name=""/>
+        <p:cNvGrpSpPr/>
+        <p:nvPr/>
+      </p:nvGrpSpPr>
+      <p:grpSpPr>
+        <a:xfrm>
+          <a:off x="0" y="0"/>
+          <a:ext cx="0" cy="0"/>
+          <a:chOff x="0" y="0"/>
+          <a:chExt cx="0" cy="0"/>
+        </a:xfrm>
+      </p:grpSpPr>
+      <p:pic>
+        <p:nvPicPr>
+          <p:cNvPr id="2" name="Image 0" descr="/home/user/bm-x7k2/sk_valuation_project/output/funding_png/s5.png">    </p:cNvPr>
           <p:cNvPicPr>
             <a:picLocks noChangeAspect="1"/>
           </p:cNvPicPr>

</xml_diff>